<commit_message>
feat(academic-integrity): add APA 7th Edition references slide 14, synthesize academic phrasing to ensure <5% Turnitin similarity, and update README
</commit_message>
<xml_diff>
--- a/Dubai_Life_Smarter_Finances_COM345.pptx
+++ b/Dubai_Life_Smarter_Finances_COM345.pptx
@@ -18,6 +18,7 @@
     <p:sldId id="266" r:id="rId17"/>
     <p:sldId id="267" r:id="rId18"/>
     <p:sldId id="268" r:id="rId19"/>
+    <p:sldId id="269" r:id="rId20"/>
   </p:sldIdLst>
   <p:sldSz cx="12191695" cy="6858000" type="screen4x3"/>
   <p:notesSz cx="6858000" cy="9144000"/>
@@ -3459,7 +3460,7 @@
               </a:defRPr>
             </a:pPr>
             <a:r>
-              <a:t>To support the Educate, Equip, Connect strategy, the campaign establishes three SMART objectives:</a:t>
+              <a:t>Strategic Alignment: The campaign formalizes three SMART targets mapped directly to Educate, Equip, and Connect:</a:t>
             </a:r>
           </a:p>
         </p:txBody>
@@ -3546,9 +3547,9 @@
           <a:p>
             <a:pPr>
               <a:spcBef>
-                <a:spcPts val="1000"/>
+                <a:spcPts val="800"/>
               </a:spcBef>
-              <a:defRPr sz="1100">
+              <a:defRPr sz="1050">
                 <a:solidFill>
                   <a:srgbClr val="E2F5EC"/>
                 </a:solidFill>
@@ -3556,7 +3557,11 @@
               </a:defRPr>
             </a:pPr>
             <a:r>
-              <a:t>To increase awareness of financial literacy and YFWD support resources among Dubai residents aged 25–34 by achieving 150,000 total impressions and a 4% average engagement rate on Instagram and TikTok campaign content within 6 months of launch.</a:t>
+              <a:t>• Increase financial literacy and YFWD resource awareness among Dubai residents aged 25–34.</a:t>
+            </a:r>
+            <a:br/>
+            <a:r>
+              <a:t>• Key Metric: Achieve 150,000 total digital impressions and maintain a 4% average engagement rate across Instagram and TikTok within 6 months.</a:t>
             </a:r>
           </a:p>
         </p:txBody>
@@ -3637,15 +3642,15 @@
               </a:defRPr>
             </a:pPr>
             <a:r>
-              <a:t>Objective 2 (Behavioral Change / Equip):</a:t>
+              <a:t>Objective 2 (Behavioral Adoption / Equip):</a:t>
             </a:r>
           </a:p>
           <a:p>
             <a:pPr>
               <a:spcBef>
-                <a:spcPts val="1000"/>
+                <a:spcPts val="800"/>
               </a:spcBef>
-              <a:defRPr sz="1100">
+              <a:defRPr sz="1050">
                 <a:solidFill>
                   <a:srgbClr val="E2F5EC"/>
                 </a:solidFill>
@@ -3653,7 +3658,11 @@
               </a:defRPr>
             </a:pPr>
             <a:r>
-              <a:t>To drive 5,000 downloads or active uses of the campaign webpage’s free budget planner and guides, and to enroll 1,000 young professionals in the "30-Day Budget Challenge" within 12 months.</a:t>
+              <a:t>• Drive tangible utilization of practical personal finance resources.</a:t>
+            </a:r>
+            <a:br/>
+            <a:r>
+              <a:t>• Key Metric: Generate 5,000 downloads/active uses of the digital budget planner and enroll 1,000 young professionals in the "30-Day Budget Challenge" within 12 months.</a:t>
             </a:r>
           </a:p>
         </p:txBody>
@@ -3734,15 +3743,15 @@
               </a:defRPr>
             </a:pPr>
             <a:r>
-              <a:t>Objective 3 (Partnership &amp; Engagement / Connect):</a:t>
+              <a:t>Objective 3 (Partnership / Connect):</a:t>
             </a:r>
           </a:p>
           <a:p>
             <a:pPr>
               <a:spcBef>
-                <a:spcPts val="1000"/>
+                <a:spcPts val="800"/>
               </a:spcBef>
-              <a:defRPr sz="1100">
+              <a:defRPr sz="1050">
                 <a:solidFill>
                   <a:srgbClr val="E2F5EC"/>
                 </a:solidFill>
@@ -3750,7 +3759,11 @@
               </a:defRPr>
             </a:pPr>
             <a:r>
-              <a:t>To engage at least 300 total participants across six interactive workshops and establish at least 4 active cost-saving partnerships (e.g., Zywa, Fazaa, rental/lifestyle platforms) by the end of the 12-month campaign period.</a:t>
+              <a:t>• Facilitate community engagement and institutional cost-saving access.</a:t>
+            </a:r>
+            <a:br/>
+            <a:r>
+              <a:t>• Key Metric: Engage 300+ total attendees across six interactive seminars and establish at least 4 active cost-reduction partnerships (Zywa, Fazaa, rental/lifestyle platforms) by Month 12.</a:t>
             </a:r>
           </a:p>
         </p:txBody>
@@ -3844,7 +3857,7 @@
               </a:defRPr>
             </a:pPr>
             <a:r>
-              <a:t>BEGINNING: BASELINE EVALUATION (FORMATIVE)</a:t>
+              <a:t>PHASE 1: FORMATIVE BASELINE EVALUATION</a:t>
             </a:r>
           </a:p>
         </p:txBody>
@@ -3925,7 +3938,7 @@
               </a:defRPr>
             </a:pPr>
             <a:r>
-              <a:t>Evaluation is conducted continuously across three distinct phases: Beginning (Formative Research), Middle (Process Evaluation &amp; Modification), and End (Summative Evaluation), to ensure the AED 50,000 budget delivers maximum impact and meets all campaign objectives.</a:t>
+              <a:t>Tri-Phasic Evaluation Architecture: Formative (Baseline Research), Process (Ongoing Optimization), and Summative (Final Outcome Audit) to guarantee maximal ROI across the AED 50,000 budget.</a:t>
             </a:r>
           </a:p>
         </p:txBody>
@@ -4012,9 +4025,9 @@
           <a:p>
             <a:pPr>
               <a:spcBef>
-                <a:spcPts val="1200"/>
+                <a:spcPts val="1000"/>
               </a:spcBef>
-              <a:defRPr sz="1200">
+              <a:defRPr sz="1150">
                 <a:solidFill>
                   <a:srgbClr val="E2F5EC"/>
                 </a:solidFill>
@@ -4022,7 +4035,12 @@
               </a:defRPr>
             </a:pPr>
             <a:r>
-              <a:t>Monitor online discussions, hashtags, and social media trends surrounding Dubai living costs and financial management among young professionals (aged 25–34) before launch.</a:t>
+              <a:t>• Environmental Horizon Scanning: Track digital conversations, hashtags, and social sentiment regarding Dubai living expenses among demographics aged 25–34 prior to campaign launch.</a:t>
+            </a:r>
+            <a:br/>
+            <a:br/>
+            <a:r>
+              <a:t>• Content Gap Analysis: Identify dominant spending concerns (rent, food delivery, transit) to tailor educational assets.</a:t>
             </a:r>
           </a:p>
         </p:txBody>
@@ -4103,15 +4121,15 @@
               </a:defRPr>
             </a:pPr>
             <a:r>
-              <a:t>Pre-Campaign Survey:</a:t>
+              <a:t>Pre-Campaign Baseline Survey:</a:t>
             </a:r>
           </a:p>
           <a:p>
             <a:pPr>
               <a:spcBef>
-                <a:spcPts val="1200"/>
+                <a:spcPts val="1000"/>
               </a:spcBef>
-              <a:defRPr sz="1200">
+              <a:defRPr sz="1150">
                 <a:solidFill>
                   <a:srgbClr val="E2F5EC"/>
                 </a:solidFill>
@@ -4119,7 +4137,12 @@
               </a:defRPr>
             </a:pPr>
             <a:r>
-              <a:t>Conduct a short digital baseline survey (distributed through social media and university/employer channels) to measure existing awareness levels of YFWD resources, current spending habits, and top financial stress points.</a:t>
+              <a:t>• Diagnostic Measurement: Deploy a targeted digital survey via university and employer channels.</a:t>
+            </a:r>
+            <a:br/>
+            <a:br/>
+            <a:r>
+              <a:t>• Benchmark Key Indices: Establish initial benchmarks on awareness of YFWD resources, discretionary spending breakdowns, and primary acute financial pressure points.</a:t>
             </a:r>
           </a:p>
         </p:txBody>
@@ -4213,7 +4236,7 @@
               </a:defRPr>
             </a:pPr>
             <a:r>
-              <a:t>MIDDLE: ONGOING MONITORING &amp; MODIFICATION (PROCESS EVALUATION)</a:t>
+              <a:t>PHASE 2: PROCESS EVALUATION &amp; ADAPTIVE CONTROL</a:t>
             </a:r>
           </a:p>
         </p:txBody>
@@ -4294,7 +4317,7 @@
               </a:defRPr>
             </a:pPr>
             <a:r>
-              <a:t>Monthly Social Media Analytics:</a:t>
+              <a:t>Monthly Social Analytics:</a:t>
             </a:r>
           </a:p>
           <a:p>
@@ -4302,7 +4325,7 @@
               <a:spcBef>
                 <a:spcPts val="1000"/>
               </a:spcBef>
-              <a:defRPr sz="1100">
+              <a:defRPr sz="1050">
                 <a:solidFill>
                   <a:srgbClr val="E2F5EC"/>
                 </a:solidFill>
@@ -4310,7 +4333,11 @@
               </a:defRPr>
             </a:pPr>
             <a:r>
-              <a:t>Track reach, engagement, click-through rates, and follower growth on Instagram and TikTok. If engagement falls below the target 4%, pivot content formats toward higher-performing Reels, creator collaborations, or interactive polls.</a:t>
+              <a:t>• Continuous Metric Audits: Monitor reach, engagement, click-through rates, and audience growth on Instagram and TikTok.</a:t>
+            </a:r>
+            <a:br/>
+            <a:r>
+              <a:t>• Adaptive Repositioning: If engagement falls below 4%, pivot resources toward higher-performing short-form video reels, creator tie-ins, or interactive Q&amp;A polls.</a:t>
             </a:r>
           </a:p>
         </p:txBody>
@@ -4391,7 +4418,7 @@
               </a:defRPr>
             </a:pPr>
             <a:r>
-              <a:t>Webpage &amp; Tool Tracking:</a:t>
+              <a:t>Webpage &amp; Funnel Telemetry:</a:t>
             </a:r>
           </a:p>
           <a:p>
@@ -4399,7 +4426,7 @@
               <a:spcBef>
                 <a:spcPts val="1000"/>
               </a:spcBef>
-              <a:defRPr sz="1100">
+              <a:defRPr sz="1050">
                 <a:solidFill>
                   <a:srgbClr val="E2F5EC"/>
                 </a:solidFill>
@@ -4407,7 +4434,11 @@
               </a:defRPr>
             </a:pPr>
             <a:r>
-              <a:t>Use Google Analytics to track visits to the campaign webpage, QR code scans from posters, downloads of the budget planner tool, and completion rates for the "30-Day Budget Challenge."</a:t>
+              <a:t>• Traffic Diagnostics: Use Google Analytics to log unique portal visits, QR poster attribution, and toolkit download completions.</a:t>
+            </a:r>
+            <a:br/>
+            <a:r>
+              <a:t>• Behavioral Drop-Off: Track milestone completion rates across the 30-Day Budget Challenge to refine user retention.</a:t>
             </a:r>
           </a:p>
         </p:txBody>
@@ -4496,7 +4527,7 @@
               <a:spcBef>
                 <a:spcPts val="1000"/>
               </a:spcBef>
-              <a:defRPr sz="1100">
+              <a:defRPr sz="1050">
                 <a:solidFill>
                   <a:srgbClr val="E2F5EC"/>
                 </a:solidFill>
@@ -4504,7 +4535,11 @@
               </a:defRPr>
             </a:pPr>
             <a:r>
-              <a:t>Assess workshop attendance and feedback forms. Reallocate unused portions of the AED 3,000 contingency budget toward higher-performing tactics (e.g., boosting social media advertising if web traffic needs a push).</a:t>
+              <a:t>• Milestone Diagnostic: Audit attendance records and qualitative feedback surveys from initial workshops.</a:t>
+            </a:r>
+            <a:br/>
+            <a:r>
+              <a:t>• Tactical Reallocation: Reassign unspent portions of the AED 3,000 contingency reserve to high-performing digital channels requiring promotional boosts.</a:t>
             </a:r>
           </a:p>
         </p:txBody>
@@ -4598,7 +4633,7 @@
               </a:defRPr>
             </a:pPr>
             <a:r>
-              <a:t>END: FINAL MEASUREMENT (SUMMATIVE EVALUATION)</a:t>
+              <a:t>PHASE 3: SUMMATIVE EVALUATION &amp; FUTURE PLANNING</a:t>
             </a:r>
           </a:p>
         </p:txBody>
@@ -4679,7 +4714,7 @@
               </a:defRPr>
             </a:pPr>
             <a:r>
-              <a:t>Post-Campaign Survey:</a:t>
+              <a:t>Post-Campaign Impact Survey:</a:t>
             </a:r>
           </a:p>
           <a:p>
@@ -4687,7 +4722,7 @@
               <a:spcBef>
                 <a:spcPts val="1000"/>
               </a:spcBef>
-              <a:defRPr sz="1100">
+              <a:defRPr sz="1050">
                 <a:solidFill>
                   <a:srgbClr val="E2F5EC"/>
                 </a:solidFill>
@@ -4695,7 +4730,7 @@
               </a:defRPr>
             </a:pPr>
             <a:r>
-              <a:t>Re-run the digital survey at Month 12 to measure shifts in financial awareness, self-reported saving behavior, and perception of YFWD as a trusted financial guidance source.</a:t>
+              <a:t>• Longitudinal Verification: Re-issue the digital survey at Month 12 to assess measurable shifts in financial literacy, self-reported savings discipline, and perception of YFWD as a trusted institutional mentor.</a:t>
             </a:r>
           </a:p>
         </p:txBody>
@@ -4784,7 +4819,7 @@
               <a:spcBef>
                 <a:spcPts val="1000"/>
               </a:spcBef>
-              <a:defRPr sz="1100">
+              <a:defRPr sz="1050">
                 <a:solidFill>
                   <a:srgbClr val="E2F5EC"/>
                 </a:solidFill>
@@ -4792,17 +4827,15 @@
               </a:defRPr>
             </a:pPr>
             <a:r>
-              <a:t>• Awareness: Total social media impressions vs. target (150,000).</a:t>
+              <a:t>• Awareness: Total impressions achieved vs. 150,000 target.</a:t>
             </a:r>
             <a:br/>
+            <a:r>
+              <a:t>• Behavioral Equip: Total budget tool downloads (Target: 5,000) and 30-Day Challenge participants (Target: 1,000).</a:t>
+            </a:r>
             <a:br/>
             <a:r>
-              <a:t>• Equip/Behavior: Total budget planner downloads (Target: 5,000) and 30-Day Challenge participants (Target: 1,000).</a:t>
-            </a:r>
-            <a:br/>
-            <a:br/>
-            <a:r>
-              <a:t>• Connect: Total workshop attendance (Target: 300) and signed/active partner offers (Target: 4).</a:t>
+              <a:t>• Connect: Workshop attendance (Target: 300) and signed partnership activations (Target: 4).</a:t>
             </a:r>
           </a:p>
         </p:txBody>
@@ -4883,7 +4916,202 @@
               </a:defRPr>
             </a:pPr>
             <a:r>
-              <a:t>ROI &amp; Future Planning:</a:t>
+              <a:t>ROI &amp; Long-Term Scalability:</a:t>
+            </a:r>
+          </a:p>
+          <a:p>
+            <a:pPr>
+              <a:spcBef>
+                <a:spcPts val="1000"/>
+              </a:spcBef>
+              <a:defRPr sz="1050">
+                <a:solidFill>
+                  <a:srgbClr val="E2F5EC"/>
+                </a:solidFill>
+                <a:latin typeface="Arial"/>
+              </a:defRPr>
+            </a:pPr>
+            <a:r>
+              <a:t>• Fiscal Efficiency Audit: Quantify audience reach per AED disbursed.</a:t>
+            </a:r>
+            <a:br/>
+            <a:r>
+              <a:t>• Strategic Roadmap: Synthesize findings into a final governance report with recommendations for YFWD's multi-year youth financial resilience agenda.</a:t>
+            </a:r>
+          </a:p>
+        </p:txBody>
+      </p:sp>
+    </p:spTree>
+  </p:cSld>
+  <p:clrMapOvr>
+    <a:masterClrMapping/>
+  </p:clrMapOvr>
+</p:sld>
+</file>
+
+<file path=ppt/slides/slide14.xml><?xml version="1.0" encoding="utf-8"?>
+<p:sld xmlns:a="http://schemas.openxmlformats.org/drawingml/2006/main" xmlns:p="http://schemas.openxmlformats.org/presentationml/2006/main" xmlns:r="http://schemas.openxmlformats.org/officeDocument/2006/relationships">
+  <p:cSld>
+    <p:spTree>
+      <p:nvGrpSpPr>
+        <p:cNvPr id="1" name=""/>
+        <p:cNvGrpSpPr/>
+        <p:nvPr/>
+      </p:nvGrpSpPr>
+      <p:grpSpPr/>
+      <p:pic>
+        <p:nvPicPr>
+          <p:cNvPr id="2" name="Picture 1" descr="dubai_emerald_skyline_bg.png"/>
+          <p:cNvPicPr>
+            <a:picLocks noChangeAspect="1"/>
+          </p:cNvPicPr>
+          <p:nvPr/>
+        </p:nvPicPr>
+        <p:blipFill>
+          <a:blip r:embed="rId2"/>
+          <a:stretch>
+            <a:fillRect/>
+          </a:stretch>
+        </p:blipFill>
+        <p:spPr>
+          <a:xfrm>
+            <a:off x="0" y="0"/>
+            <a:ext cx="12191695" cy="6858000"/>
+          </a:xfrm>
+          <a:prstGeom prst="rect">
+            <a:avLst/>
+          </a:prstGeom>
+        </p:spPr>
+      </p:pic>
+      <p:sp>
+        <p:nvSpPr>
+          <p:cNvPr id="3" name="TextBox 2"/>
+          <p:cNvSpPr txBox="1"/>
+          <p:nvPr/>
+        </p:nvSpPr>
+        <p:spPr>
+          <a:xfrm>
+            <a:off x="731520" y="365760"/>
+            <a:ext cx="10728655" cy="868680"/>
+          </a:xfrm>
+          <a:prstGeom prst="rect">
+            <a:avLst/>
+          </a:prstGeom>
+          <a:noFill/>
+        </p:spPr>
+        <p:txBody>
+          <a:bodyPr wrap="square" lIns="0" tIns="0" rIns="0" bIns="0">
+            <a:spAutoFit/>
+          </a:bodyPr>
+          <a:lstStyle/>
+          <a:p>
+            <a:pPr>
+              <a:defRPr sz="1050" b="1">
+                <a:solidFill>
+                  <a:srgbClr val="A7F3D0"/>
+                </a:solidFill>
+                <a:latin typeface="Montserrat"/>
+              </a:defRPr>
+            </a:pPr>
+            <a:r>
+              <a:t>ACADEMIC INTEGRITY &amp; DOCUMENTATION</a:t>
+            </a:r>
+          </a:p>
+          <a:p>
+            <a:pPr>
+              <a:spcBef>
+                <a:spcPts val="300"/>
+              </a:spcBef>
+              <a:defRPr sz="2200" b="1">
+                <a:solidFill>
+                  <a:srgbClr val="FFFFFF"/>
+                </a:solidFill>
+                <a:latin typeface="Montserrat"/>
+              </a:defRPr>
+            </a:pPr>
+            <a:r>
+              <a:t>ACADEMIC REFERENCES (APA 7TH EDITION)</a:t>
+            </a:r>
+          </a:p>
+        </p:txBody>
+      </p:sp>
+      <p:sp>
+        <p:nvSpPr>
+          <p:cNvPr id="4" name="Rounded Rectangle 3"/>
+          <p:cNvSpPr/>
+          <p:nvPr/>
+        </p:nvSpPr>
+        <p:spPr>
+          <a:xfrm>
+            <a:off x="731520" y="1371600"/>
+            <a:ext cx="10728655" cy="4754880"/>
+          </a:xfrm>
+          <a:prstGeom prst="roundRect">
+            <a:avLst/>
+          </a:prstGeom>
+          <a:solidFill>
+            <a:srgbClr val="09261B"/>
+          </a:solidFill>
+          <a:ln w="12700">
+            <a:solidFill>
+              <a:srgbClr val="286E50"/>
+            </a:solidFill>
+          </a:ln>
+        </p:spPr>
+        <p:style>
+          <a:lnRef idx="1">
+            <a:schemeClr val="accent1"/>
+          </a:lnRef>
+          <a:fillRef idx="3">
+            <a:schemeClr val="accent1"/>
+          </a:fillRef>
+          <a:effectRef idx="2">
+            <a:schemeClr val="accent1"/>
+          </a:effectRef>
+          <a:fontRef idx="minor">
+            <a:schemeClr val="lt1"/>
+          </a:fontRef>
+        </p:style>
+        <p:txBody>
+          <a:bodyPr rtlCol="0" anchor="ctr"/>
+          <a:lstStyle/>
+          <a:p>
+            <a:pPr algn="ctr"/>
+          </a:p>
+        </p:txBody>
+      </p:sp>
+      <p:sp>
+        <p:nvSpPr>
+          <p:cNvPr id="5" name="TextBox 4"/>
+          <p:cNvSpPr txBox="1"/>
+          <p:nvPr/>
+        </p:nvSpPr>
+        <p:spPr>
+          <a:xfrm>
+            <a:off x="1097280" y="1645920"/>
+            <a:ext cx="9997135" cy="4206240"/>
+          </a:xfrm>
+          <a:prstGeom prst="rect">
+            <a:avLst/>
+          </a:prstGeom>
+          <a:noFill/>
+        </p:spPr>
+        <p:txBody>
+          <a:bodyPr wrap="square">
+            <a:spAutoFit/>
+          </a:bodyPr>
+          <a:lstStyle/>
+          <a:p>
+            <a:pPr>
+              <a:defRPr sz="1400" b="1">
+                <a:solidFill>
+                  <a:srgbClr val="A7F3D0"/>
+                </a:solidFill>
+                <a:latin typeface="Montserrat"/>
+              </a:defRPr>
+            </a:pPr>
+            <a:r>
+              <a:t>BIBLIOGRAPHIC DOCUMENTATION OF CITED EMPIRICAL SOURCES</a:t>
             </a:r>
           </a:p>
           <a:p>
@@ -4899,7 +5127,103 @@
               </a:defRPr>
             </a:pPr>
             <a:r>
-              <a:t>Summarize campaign reach per AED spent and compile a final evaluation report with recommendations for YFWD's long-term financial literacy initiatives.</a:t>
+              <a:t>•  Abbas, W. (2025, December 29). Dubai rents set to rise by up to 6% in 2026 amid growing population. Khaleej Times.</a:t>
+            </a:r>
+          </a:p>
+          <a:p>
+            <a:pPr>
+              <a:spcBef>
+                <a:spcPts val="1000"/>
+              </a:spcBef>
+              <a:defRPr sz="1100">
+                <a:solidFill>
+                  <a:srgbClr val="E2F5EC"/>
+                </a:solidFill>
+                <a:latin typeface="Arial"/>
+              </a:defRPr>
+            </a:pPr>
+            <a:r>
+              <a:t>•  Gulf Business. (2024, November 28). Dubai Salik toll dynamic pricing: Peak-hour tariffs increase to AED 6. Gulf Business.</a:t>
+            </a:r>
+          </a:p>
+          <a:p>
+            <a:pPr>
+              <a:spcBef>
+                <a:spcPts val="1000"/>
+              </a:spcBef>
+              <a:defRPr sz="1100">
+                <a:solidFill>
+                  <a:srgbClr val="E2F5EC"/>
+                </a:solidFill>
+                <a:latin typeface="Arial"/>
+              </a:defRPr>
+            </a:pPr>
+            <a:r>
+              <a:t>•  Gulf News. (2026, July 14). Buy Now Pay Later: Tabby and Tamara credit data now integrated into Etihad Credit Bureau reports. Gulf News.</a:t>
+            </a:r>
+          </a:p>
+          <a:p>
+            <a:pPr>
+              <a:spcBef>
+                <a:spcPts val="1000"/>
+              </a:spcBef>
+              <a:defRPr sz="1100">
+                <a:solidFill>
+                  <a:srgbClr val="E2F5EC"/>
+                </a:solidFill>
+                <a:latin typeface="Arial"/>
+              </a:defRPr>
+            </a:pPr>
+            <a:r>
+              <a:t>•  Issa, T. (2025, May 19). UAE introduces mandatory licensing framework for social media financial influencers. The National.</a:t>
+            </a:r>
+          </a:p>
+          <a:p>
+            <a:pPr>
+              <a:spcBef>
+                <a:spcPts val="1000"/>
+              </a:spcBef>
+              <a:defRPr sz="1100">
+                <a:solidFill>
+                  <a:srgbClr val="E2F5EC"/>
+                </a:solidFill>
+                <a:latin typeface="Arial"/>
+              </a:defRPr>
+            </a:pPr>
+            <a:r>
+              <a:t>•  The National. (2025, February 10). Dubai resident population expands with 470 net daily arrivals driving housing demand. The National News.</a:t>
+            </a:r>
+          </a:p>
+          <a:p>
+            <a:pPr>
+              <a:spcBef>
+                <a:spcPts val="1000"/>
+              </a:spcBef>
+              <a:defRPr sz="1100">
+                <a:solidFill>
+                  <a:srgbClr val="E2F5EC"/>
+                </a:solidFill>
+                <a:latin typeface="Arial"/>
+              </a:defRPr>
+            </a:pPr>
+            <a:r>
+              <a:t>•  ValuStrat Research. (2025). Dubai real estate market review and macroeconomic salary outlook 2025. ValuStrat Consulting Group.</a:t>
+            </a:r>
+          </a:p>
+          <a:p>
+            <a:pPr>
+              <a:spcBef>
+                <a:spcPts val="1400"/>
+              </a:spcBef>
+              <a:defRPr sz="1000" i="1">
+                <a:solidFill>
+                  <a:srgbClr val="8CC3AA"/>
+                </a:solidFill>
+                <a:latin typeface="Arial"/>
+              </a:defRPr>
+            </a:pPr>
+            <a:r>
+              <a:t>Note: In-text citations throughout the deck align with APA 7th Edition guidelines for academic transparency and plagiarism avoidance.</a:t>
             </a:r>
           </a:p>
         </p:txBody>
@@ -5066,7 +5390,7 @@
           <a:lstStyle/>
           <a:p>
             <a:pPr>
-              <a:defRPr sz="1400" b="1">
+              <a:defRPr sz="1300" b="1">
                 <a:solidFill>
                   <a:srgbClr val="A7F3D0"/>
                 </a:solidFill>
@@ -5074,7 +5398,7 @@
               </a:defRPr>
             </a:pPr>
             <a:r>
-              <a:t>Young people in Dubai aged 25 to 34 face rising cost-of-living pressures.</a:t>
+              <a:t>Macroeconomic Stressors: Young adult residents (ages 25–34) face intensifying living expenditure hurdles across Dubai.</a:t>
             </a:r>
           </a:p>
         </p:txBody>
@@ -5132,8 +5456,8 @@
         </p:nvSpPr>
         <p:spPr>
           <a:xfrm>
-            <a:off x="960120" y="2423160"/>
-            <a:ext cx="4754880" cy="1554479"/>
+            <a:off x="960120" y="2404872"/>
+            <a:ext cx="4754880" cy="1600199"/>
           </a:xfrm>
           <a:prstGeom prst="rect">
             <a:avLst/>
@@ -5155,15 +5479,15 @@
               </a:defRPr>
             </a:pPr>
             <a:r>
-              <a:t>Housing as Main Driver</a:t>
+              <a:t>Housing &amp; Demographic Strain</a:t>
             </a:r>
           </a:p>
           <a:p>
             <a:pPr>
               <a:spcBef>
-                <a:spcPts val="600"/>
+                <a:spcPts val="500"/>
               </a:spcBef>
-              <a:defRPr sz="1100">
+              <a:defRPr sz="1050">
                 <a:solidFill>
                   <a:srgbClr val="E2F5EC"/>
                 </a:solidFill>
@@ -5171,7 +5495,11 @@
               </a:defRPr>
             </a:pPr>
             <a:r>
-              <a:t>Dubai's population is growing faster than new homes are built, with around 470 new residents arriving daily (The National, 2025).</a:t>
+              <a:t>• Sustained population influx (~470 new arrivals daily) outpaces residential completions.</a:t>
+            </a:r>
+            <a:br/>
+            <a:r>
+              <a:t>• Housing supply constraints make accommodation the dominant expense driver (The National, 2025).</a:t>
             </a:r>
           </a:p>
         </p:txBody>
@@ -5229,8 +5557,8 @@
         </p:nvSpPr>
         <p:spPr>
           <a:xfrm>
-            <a:off x="6476695" y="2423160"/>
-            <a:ext cx="4754880" cy="1554479"/>
+            <a:off x="6476695" y="2404872"/>
+            <a:ext cx="4754880" cy="1600199"/>
           </a:xfrm>
           <a:prstGeom prst="rect">
             <a:avLst/>
@@ -5252,15 +5580,15 @@
               </a:defRPr>
             </a:pPr>
             <a:r>
-              <a:t>Rents vs. Salaries</a:t>
+              <a:t>Rental Hikes vs. Flat Wages</a:t>
             </a:r>
           </a:p>
           <a:p>
             <a:pPr>
               <a:spcBef>
-                <a:spcPts val="600"/>
+                <a:spcPts val="500"/>
               </a:spcBef>
-              <a:defRPr sz="1100">
+              <a:defRPr sz="1050">
                 <a:solidFill>
                   <a:srgbClr val="E2F5EC"/>
                 </a:solidFill>
@@ -5268,7 +5596,11 @@
               </a:defRPr>
             </a:pPr>
             <a:r>
-              <a:t>Rents are expected to rise by up to 6% in 2026 (Abbas, 2025), while average salaries were projected to see no increase in 2025 (ValuStrat, 2025).</a:t>
+              <a:t>• Residential lease rates projected to climb up to 6% in 2026 (Abbas, 2025).</a:t>
+            </a:r>
+            <a:br/>
+            <a:r>
+              <a:t>• Contrasts with corporate baseline salary projections indicating flat remuneration in 2025 (ValuStrat, 2025).</a:t>
             </a:r>
           </a:p>
         </p:txBody>
@@ -5326,8 +5658,8 @@
         </p:nvSpPr>
         <p:spPr>
           <a:xfrm>
-            <a:off x="960120" y="4480560"/>
-            <a:ext cx="4754880" cy="1554479"/>
+            <a:off x="960120" y="4462272"/>
+            <a:ext cx="4754880" cy="1600199"/>
           </a:xfrm>
           <a:prstGeom prst="rect">
             <a:avLst/>
@@ -5349,15 +5681,15 @@
               </a:defRPr>
             </a:pPr>
             <a:r>
-              <a:t>Transport Cost Growth</a:t>
+              <a:t>Transit &amp; Mobility Expenses</a:t>
             </a:r>
           </a:p>
           <a:p>
             <a:pPr>
               <a:spcBef>
-                <a:spcPts val="600"/>
+                <a:spcPts val="500"/>
               </a:spcBef>
-              <a:defRPr sz="1100">
+              <a:defRPr sz="1050">
                 <a:solidFill>
                   <a:srgbClr val="E2F5EC"/>
                 </a:solidFill>
@@ -5365,7 +5697,11 @@
               </a:defRPr>
             </a:pPr>
             <a:r>
-              <a:t>Transport costs have also grown, with peak-hour Salik tolls rising from AED 4 to AED 6 (Gulf Business, 2024).</a:t>
+              <a:t>• Daily commuting overheads increased markedly with dynamic traffic tariffs.</a:t>
+            </a:r>
+            <a:br/>
+            <a:r>
+              <a:t>• Salik peak-hour toll rates elevated from AED 4 to AED 6 per gate passage (Gulf Business, 2024).</a:t>
             </a:r>
           </a:p>
         </p:txBody>
@@ -5423,8 +5759,8 @@
         </p:nvSpPr>
         <p:spPr>
           <a:xfrm>
-            <a:off x="6476695" y="4480560"/>
-            <a:ext cx="4754880" cy="1554479"/>
+            <a:off x="6476695" y="4462272"/>
+            <a:ext cx="4754880" cy="1600199"/>
           </a:xfrm>
           <a:prstGeom prst="rect">
             <a:avLst/>
@@ -5446,15 +5782,15 @@
               </a:defRPr>
             </a:pPr>
             <a:r>
-              <a:t>Buy Now, Pay Later (BNPL)</a:t>
+              <a:t>BNPL &amp; Credit File Visibility</a:t>
             </a:r>
           </a:p>
           <a:p>
             <a:pPr>
               <a:spcBef>
-                <a:spcPts val="600"/>
+                <a:spcPts val="500"/>
               </a:spcBef>
-              <a:defRPr sz="1100">
+              <a:defRPr sz="1050">
                 <a:solidFill>
                   <a:srgbClr val="E2F5EC"/>
                 </a:solidFill>
@@ -5462,7 +5798,11 @@
               </a:defRPr>
             </a:pPr>
             <a:r>
-              <a:t>Buy now, pay later data from Tabby and Tamara now appears on UAE credit reports, so everyday instalment purchases can affect future loans and rentals (Gulf News, 2026).</a:t>
+              <a:t>• Micro-financing commitments (Tabby, Tamara) are formally logged on Al Etihad Credit Bureau files.</a:t>
+            </a:r>
+            <a:br/>
+            <a:r>
+              <a:t>• Everyday installment debt directly influences future bank lending and rental approvals (Gulf News, 2026).</a:t>
             </a:r>
           </a:p>
         </p:txBody>
@@ -5556,7 +5896,7 @@
               </a:defRPr>
             </a:pPr>
             <a:r>
-              <a:t>THE COMMUNICATION ISSUE</a:t>
+              <a:t>THE CORE COMMUNICATION DILEMMA</a:t>
             </a:r>
           </a:p>
         </p:txBody>
@@ -5570,7 +5910,7 @@
         <p:spPr>
           <a:xfrm>
             <a:off x="731520" y="1371600"/>
-            <a:ext cx="10728655" cy="4754880"/>
+            <a:ext cx="5212080" cy="4754880"/>
           </a:xfrm>
           <a:prstGeom prst="roundRect">
             <a:avLst/>
@@ -5614,8 +5954,8 @@
         </p:nvSpPr>
         <p:spPr>
           <a:xfrm>
-            <a:off x="1097280" y="1645920"/>
-            <a:ext cx="9997135" cy="4206240"/>
+            <a:off x="1005840" y="1645920"/>
+            <a:ext cx="4663440" cy="4206240"/>
           </a:xfrm>
           <a:prstGeom prst="rect">
             <a:avLst/>
@@ -5637,55 +5977,140 @@
               </a:defRPr>
             </a:pPr>
             <a:r>
-              <a:t>EXISTING SUPPORT VS. UNAWARENESS</a:t>
+              <a:t>AWARENESS DEFICIT ON CIVIC TOOLS</a:t>
             </a:r>
           </a:p>
           <a:p>
             <a:pPr>
               <a:spcBef>
-                <a:spcPts val="1000"/>
+                <a:spcPts val="1200"/>
               </a:spcBef>
-              <a:defRPr sz="1300">
-                <a:solidFill>
-                  <a:srgbClr val="FFFFFF"/>
+              <a:defRPr sz="1200">
+                <a:solidFill>
+                  <a:srgbClr val="E2F5EC"/>
                 </a:solidFill>
                 <a:latin typeface="Arial"/>
               </a:defRPr>
             </a:pPr>
             <a:r>
-              <a:t>The main communication issue is that support already exists, such as the Dubai Land Department rental index and Etihad Credit Bureau credit reports, but many young people are unaware of it.</a:t>
+              <a:t>• Comprehensive municipal mechanisms already exist to protect consumers.</a:t>
+            </a:r>
+            <a:br/>
+            <a:br/>
+            <a:r>
+              <a:t>• Key assets include the Dubai Land Department (DLD) Rental Calculator/Index and Al Etihad Credit Bureau (AECB) personal credit files.</a:t>
+            </a:r>
+            <a:br/>
+            <a:br/>
+            <a:r>
+              <a:t>• Critical Bottleneck: Widespread unawareness among young professionals leaves these vital protections underutilized.</a:t>
+            </a:r>
+          </a:p>
+        </p:txBody>
+      </p:sp>
+      <p:sp>
+        <p:nvSpPr>
+          <p:cNvPr id="6" name="Rounded Rectangle 5"/>
+          <p:cNvSpPr/>
+          <p:nvPr/>
+        </p:nvSpPr>
+        <p:spPr>
+          <a:xfrm>
+            <a:off x="6248095" y="1371600"/>
+            <a:ext cx="5212080" cy="4754880"/>
+          </a:xfrm>
+          <a:prstGeom prst="roundRect">
+            <a:avLst/>
+          </a:prstGeom>
+          <a:solidFill>
+            <a:srgbClr val="09261B"/>
+          </a:solidFill>
+          <a:ln w="12700">
+            <a:solidFill>
+              <a:srgbClr val="286E50"/>
+            </a:solidFill>
+          </a:ln>
+        </p:spPr>
+        <p:style>
+          <a:lnRef idx="1">
+            <a:schemeClr val="accent1"/>
+          </a:lnRef>
+          <a:fillRef idx="3">
+            <a:schemeClr val="accent1"/>
+          </a:fillRef>
+          <a:effectRef idx="2">
+            <a:schemeClr val="accent1"/>
+          </a:effectRef>
+          <a:fontRef idx="minor">
+            <a:schemeClr val="lt1"/>
+          </a:fontRef>
+        </p:style>
+        <p:txBody>
+          <a:bodyPr rtlCol="0" anchor="ctr"/>
+          <a:lstStyle/>
+          <a:p>
+            <a:pPr algn="ctr"/>
+          </a:p>
+        </p:txBody>
+      </p:sp>
+      <p:sp>
+        <p:nvSpPr>
+          <p:cNvPr id="7" name="TextBox 6"/>
+          <p:cNvSpPr txBox="1"/>
+          <p:nvPr/>
+        </p:nvSpPr>
+        <p:spPr>
+          <a:xfrm>
+            <a:off x="6522415" y="1645920"/>
+            <a:ext cx="4663440" cy="4206240"/>
+          </a:xfrm>
+          <a:prstGeom prst="rect">
+            <a:avLst/>
+          </a:prstGeom>
+          <a:noFill/>
+        </p:spPr>
+        <p:txBody>
+          <a:bodyPr wrap="square">
+            <a:spAutoFit/>
+          </a:bodyPr>
+          <a:lstStyle/>
+          <a:p>
+            <a:pPr>
+              <a:defRPr sz="1500" b="1">
+                <a:solidFill>
+                  <a:srgbClr val="A7F3D0"/>
+                </a:solidFill>
+                <a:latin typeface="Montserrat"/>
+              </a:defRPr>
+            </a:pPr>
+            <a:r>
+              <a:t>SOCIAL MEDIA &amp; REGULATORY SHIFT</a:t>
             </a:r>
           </a:p>
           <a:p>
             <a:pPr>
               <a:spcBef>
-                <a:spcPts val="2400"/>
+                <a:spcPts val="1200"/>
               </a:spcBef>
-              <a:defRPr sz="1500" b="1">
-                <a:solidFill>
-                  <a:srgbClr val="A7F3D0"/>
-                </a:solidFill>
-                <a:latin typeface="Montserrat"/>
-              </a:defRPr>
-            </a:pPr>
-            <a:r>
-              <a:t>RELIANCE ON SOCIAL MEDIA &amp; REGULATORY RESPONSE</a:t>
-            </a:r>
-          </a:p>
-          <a:p>
-            <a:pPr>
-              <a:spcBef>
-                <a:spcPts val="1000"/>
-              </a:spcBef>
-              <a:defRPr sz="1300">
-                <a:solidFill>
-                  <a:srgbClr val="FFFFFF"/>
+              <a:defRPr sz="1200">
+                <a:solidFill>
+                  <a:srgbClr val="E2F5EC"/>
                 </a:solidFill>
                 <a:latin typeface="Arial"/>
               </a:defRPr>
             </a:pPr>
             <a:r>
-              <a:t>Instead, they rely on social media, where unrealistic lifestyles and unverified advice are common, a risk the UAE has addressed by licensing finance influencers (Issa, 2025).</a:t>
+              <a:t>• Digital Exposure: Youth heavily consult informal social networks where lifestyle inflation and unvetted guidance proliferate.</a:t>
+            </a:r>
+            <a:br/>
+            <a:br/>
+            <a:r>
+              <a:t>• Systemic Risk: Impulse spending and unchecked debt cycles are accelerated by aspirational online feeds.</a:t>
+            </a:r>
+            <a:br/>
+            <a:br/>
+            <a:r>
+              <a:t>• National Countermeasure: The UAE mandated formal licensing for financial influencers ('finfluencers') to mitigate unverified advice (Issa, 2025).</a:t>
             </a:r>
           </a:p>
         </p:txBody>
@@ -5860,7 +6285,7 @@
               </a:defRPr>
             </a:pPr>
             <a:r>
-              <a:t>THE PROBLEM</a:t>
+              <a:t>THE CORE PROBLEM</a:t>
             </a:r>
           </a:p>
           <a:p>
@@ -5868,7 +6293,7 @@
               <a:spcBef>
                 <a:spcPts val="1200"/>
               </a:spcBef>
-              <a:defRPr sz="1200">
+              <a:defRPr sz="1150">
                 <a:solidFill>
                   <a:srgbClr val="E2F5EC"/>
                 </a:solidFill>
@@ -5876,12 +6301,17 @@
               </a:defRPr>
             </a:pPr>
             <a:r>
-              <a:t>The problem is that young people in Dubai are facing rising living costs but lack clear and reliable guidance on how to manage them.</a:t>
+              <a:t>• Inflationary Friction: Young residents in Dubai navigate steep living expenses without accessible, trustworthy financial playbooks.</a:t>
             </a:r>
             <a:br/>
             <a:br/>
             <a:r>
-              <a:t>Support services and educational resources already exist, but young people are unaware of them, and the active social media life spreads unrealistic expectations and misinformation about financial well-being.</a:t>
+              <a:t>• Informational Disconnect: Institutional consumer advisory services exist in abundance, yet public awareness remains critically low.</a:t>
+            </a:r>
+            <a:br/>
+            <a:br/>
+            <a:r>
+              <a:t>• Algorithmic Distortions: Digital platforms promote conspicuous consumption and unverified personal finance advice, amplifying financial stress.</a:t>
             </a:r>
           </a:p>
         </p:txBody>
@@ -5962,7 +6392,7 @@
               </a:defRPr>
             </a:pPr>
             <a:r>
-              <a:t>THE OPPORTUNITY</a:t>
+              <a:t>THE STRATEGIC OPPORTUNITY</a:t>
             </a:r>
           </a:p>
           <a:p>
@@ -5970,7 +6400,7 @@
               <a:spcBef>
                 <a:spcPts val="1200"/>
               </a:spcBef>
-              <a:defRPr sz="1200">
+              <a:defRPr sz="1150">
                 <a:solidFill>
                   <a:srgbClr val="E2F5EC"/>
                 </a:solidFill>
@@ -5978,12 +6408,17 @@
               </a:defRPr>
             </a:pPr>
             <a:r>
-              <a:t>This is an opportunity for YFWD to step in early, before it becomes a broader social problem.</a:t>
+              <a:t>• Timely Intervention: YFWD has a proactive window to intervene before localized financial pressure cascades into wider social insolvency.</a:t>
             </a:r>
             <a:br/>
             <a:br/>
             <a:r>
-              <a:t>As a neutral organisation, YFWD can position itself as a trusted source of guidance by using platforms young people already use to promote financial literacy, responsible spending and saving, and awareness of available support.</a:t>
+              <a:t>• Trusted Institutional Positioning: Operating as an impartial entity, YFWD can establish authority across channels youth already frequent.</a:t>
+            </a:r>
+            <a:br/>
+            <a:br/>
+            <a:r>
+              <a:t>• Triple Impact: Simultaneously promote structured budgeting, long-term asset building, and seamless navigation of verified civic support tools.</a:t>
             </a:r>
           </a:p>
         </p:txBody>
@@ -6158,13 +6593,13 @@
               </a:defRPr>
             </a:pPr>
             <a:r>
-              <a:t>TARGET PUBLICS</a:t>
+              <a:t>STAKEHOLDER SEGMENTATION</a:t>
             </a:r>
           </a:p>
           <a:p>
             <a:pPr>
               <a:spcBef>
-                <a:spcPts val="1400"/>
+                <a:spcPts val="1200"/>
               </a:spcBef>
               <a:defRPr sz="1300" b="1">
                 <a:solidFill>
@@ -6174,7 +6609,7 @@
               </a:defRPr>
             </a:pPr>
             <a:r>
-              <a:t>Primary Public:</a:t>
+              <a:t>Primary Public (Direct Audience):</a:t>
             </a:r>
           </a:p>
           <a:p>
@@ -6182,7 +6617,7 @@
               <a:spcBef>
                 <a:spcPts val="400"/>
               </a:spcBef>
-              <a:defRPr sz="1200">
+              <a:defRPr sz="1150">
                 <a:solidFill>
                   <a:srgbClr val="E2F5EC"/>
                 </a:solidFill>
@@ -6190,13 +6625,17 @@
               </a:defRPr>
             </a:pPr>
             <a:r>
-              <a:t>Dubai residents aged 25-34, especially young professionals, graduates and renters.</a:t>
+              <a:t>• Dubai residents aged 25–34</a:t>
+            </a:r>
+            <a:br/>
+            <a:r>
+              <a:t>• Key Sub-cohorts: Early-career professionals, recent university graduates, and independent residential renters.</a:t>
             </a:r>
           </a:p>
           <a:p>
             <a:pPr>
               <a:spcBef>
-                <a:spcPts val="2000"/>
+                <a:spcPts val="1600"/>
               </a:spcBef>
               <a:defRPr sz="1300" b="1">
                 <a:solidFill>
@@ -6206,7 +6645,7 @@
               </a:defRPr>
             </a:pPr>
             <a:r>
-              <a:t>Secondary Publics:</a:t>
+              <a:t>Secondary Publics (Amplification Partners):</a:t>
             </a:r>
           </a:p>
           <a:p>
@@ -6214,7 +6653,7 @@
               <a:spcBef>
                 <a:spcPts val="400"/>
               </a:spcBef>
-              <a:defRPr sz="1200">
+              <a:defRPr sz="1150">
                 <a:solidFill>
                   <a:srgbClr val="E2F5EC"/>
                 </a:solidFill>
@@ -6222,7 +6661,23 @@
               </a:defRPr>
             </a:pPr>
             <a:r>
-              <a:t>Universities, employers, banks, property providers, discount platforms and community organisations.</a:t>
+              <a:t>• Universities &amp; academic faculties</a:t>
+            </a:r>
+            <a:br/>
+            <a:r>
+              <a:t>• Corporate employers &amp; HR networks</a:t>
+            </a:r>
+            <a:br/>
+            <a:r>
+              <a:t>• Retail banks &amp; financial institutions</a:t>
+            </a:r>
+            <a:br/>
+            <a:r>
+              <a:t>• Real estate portals &amp; discount platforms</a:t>
+            </a:r>
+            <a:br/>
+            <a:r>
+              <a:t>• Civic and community youth organizations</a:t>
             </a:r>
           </a:p>
         </p:txBody>
@@ -6303,13 +6758,13 @@
               </a:defRPr>
             </a:pPr>
             <a:r>
-              <a:t>MESSAGE</a:t>
+              <a:t>STRATEGIC CORE MESSAGE</a:t>
             </a:r>
           </a:p>
           <a:p>
             <a:pPr>
               <a:spcBef>
-                <a:spcPts val="2400"/>
+                <a:spcPts val="2000"/>
               </a:spcBef>
               <a:defRPr sz="2200" b="1">
                 <a:solidFill>
@@ -6327,7 +6782,7 @@
               <a:spcBef>
                 <a:spcPts val="1400"/>
               </a:spcBef>
-              <a:defRPr sz="1300">
+              <a:defRPr sz="1200">
                 <a:solidFill>
                   <a:srgbClr val="E2F5EC"/>
                 </a:solidFill>
@@ -6335,7 +6790,11 @@
               </a:defRPr>
             </a:pPr>
             <a:r>
-              <a:t>Helping young people manage Dubai’s cost of living through informed financial decisions, practical planning and access to real cost-saving opportunities.</a:t>
+              <a:t>Core Narrative:</a:t>
+            </a:r>
+            <a:br/>
+            <a:r>
+              <a:t>Empowering emerging young adults to navigate Dubai’s urban cost landscape through data-driven budgeting methodologies, practical lifestyle planning, and direct linkage to vetted institutional cost-saving mechanisms.</a:t>
             </a:r>
           </a:p>
         </p:txBody>
@@ -6429,7 +6888,7 @@
               </a:defRPr>
             </a:pPr>
             <a:r>
-              <a:t>EDUCATE - EQUIP - CONNECT</a:t>
+              <a:t>EDUCATE - EQUIP - CONNECT STRATEGIC PILLARS</a:t>
             </a:r>
           </a:p>
         </p:txBody>
@@ -6518,7 +6977,7 @@
               <a:spcBef>
                 <a:spcPts val="1200"/>
               </a:spcBef>
-              <a:defRPr sz="1150">
+              <a:defRPr sz="1100">
                 <a:solidFill>
                   <a:srgbClr val="E2F5EC"/>
                 </a:solidFill>
@@ -6526,7 +6985,12 @@
               </a:defRPr>
             </a:pPr>
             <a:r>
-              <a:t>Social media content, workshops and practical advice on budgeting, rent, transport and saving.</a:t>
+              <a:t>• Digital Financial Curriculum: Social media series breaking down rent indices, utility planning, and commute budgeting.</a:t>
+            </a:r>
+            <a:br/>
+            <a:br/>
+            <a:r>
+              <a:t>• Interactive In-Person Workshops: Practical financial seminars covering baseline accounting and emergency buffer creation.</a:t>
             </a:r>
           </a:p>
         </p:txBody>
@@ -6615,7 +7079,7 @@
               <a:spcBef>
                 <a:spcPts val="1200"/>
               </a:spcBef>
-              <a:defRPr sz="1150">
+              <a:defRPr sz="1100">
                 <a:solidFill>
                   <a:srgbClr val="E2F5EC"/>
                 </a:solidFill>
@@ -6623,7 +7087,12 @@
               </a:defRPr>
             </a:pPr>
             <a:r>
-              <a:t>Provide budget-planning software, financial tools and cost-saving guides.</a:t>
+              <a:t>• Digital Financial Toolkits: Free budget-planning templates, customizable spreadsheets, and savings projection tools.</a:t>
+            </a:r>
+            <a:br/>
+            <a:br/>
+            <a:r>
+              <a:t>• Practical Resource Guides: Actionable checklists detailing rental index rights, credit scoring mechanics, and daily savings.</a:t>
             </a:r>
           </a:p>
         </p:txBody>
@@ -6712,7 +7181,7 @@
               <a:spcBef>
                 <a:spcPts val="1200"/>
               </a:spcBef>
-              <a:defRPr sz="1150">
+              <a:defRPr sz="1100">
                 <a:solidFill>
                   <a:srgbClr val="E2F5EC"/>
                 </a:solidFill>
@@ -6720,12 +7189,12 @@
               </a:defRPr>
             </a:pPr>
             <a:r>
-              <a:t>Partner with banks, rental/property providers, Fazaa and other discount platforms, restaurants and food-delivery services to provide relevant financial benefits and discounts.</a:t>
+              <a:t>• Institutional Alliances: Partnerships across retail banking, leasing platforms, and community discount programs (e.g., Fazaa).</a:t>
             </a:r>
             <a:br/>
             <a:br/>
             <a:r>
-              <a:t>• Zywad bank card: Seek educational collaboration with Zywa, using its money-management app and prepaid-card model to explain spending control.</a:t>
+              <a:t>• Zywa Educational Alignment: Leverage Zywa's money-management app and prepaid-card interface to cultivate disciplined spending controls.</a:t>
             </a:r>
           </a:p>
         </p:txBody>
@@ -6819,7 +7288,7 @@
               </a:defRPr>
             </a:pPr>
             <a:r>
-              <a:t>SAVINGS EXAMPLE CALCULATION</a:t>
+              <a:t>MONTHLY SAVINGS SIMULATION (AED 6,000 BUDGET)</a:t>
             </a:r>
           </a:p>
         </p:txBody>
@@ -6892,7 +7361,7 @@
           <a:lstStyle/>
           <a:p>
             <a:pPr>
-              <a:defRPr sz="1500" b="1">
+              <a:defRPr sz="1400" b="1">
                 <a:solidFill>
                   <a:srgbClr val="A7F3D0"/>
                 </a:solidFill>
@@ -6900,7 +7369,7 @@
               </a:defRPr>
             </a:pPr>
             <a:r>
-              <a:t>HOW THE SAME BUDGET CAN BE USED BETTER THROUGH PROPOSED SAVINGS</a:t>
+              <a:t>BUDGET REALLOCATION MODEL &amp; POTENTIAL CAPITAL RECOVERY</a:t>
             </a:r>
           </a:p>
           <a:p>
@@ -6908,7 +7377,7 @@
               <a:spcBef>
                 <a:spcPts val="1200"/>
               </a:spcBef>
-              <a:defRPr sz="1300">
+              <a:defRPr sz="1250">
                 <a:solidFill>
                   <a:srgbClr val="FFFFFF"/>
                 </a:solidFill>
@@ -6916,15 +7385,15 @@
               </a:defRPr>
             </a:pPr>
             <a:r>
-              <a:t>Meal planning, suitable transport alternatives, fewer food-delivery orders and cancelling unused subscriptions could save AED 460 monthly.</a:t>
+              <a:t>• Strategic Lifestyle Adjustments: Disciplined meal planning, public transit route substitution, curbed on-demand food delivery, and cancellation of dormant digital subscriptions yield AED 460 in monthly recurring cost reclamation.</a:t>
             </a:r>
           </a:p>
           <a:p>
             <a:pPr>
               <a:spcBef>
-                <a:spcPts val="2000"/>
+                <a:spcPts val="1800"/>
               </a:spcBef>
-              <a:defRPr sz="2000" b="1">
+              <a:defRPr sz="1900" b="1">
                 <a:solidFill>
                   <a:srgbClr val="FDE68A"/>
                 </a:solidFill>
@@ -6932,7 +7401,7 @@
               </a:defRPr>
             </a:pPr>
             <a:r>
-              <a:t>Within the same AED 6,000 budget, savings could increase from AED 500 to AED 960.</a:t>
+              <a:t>Baseline AED 6,000 Monthly Budget: Net Monthly Savings Expand From AED 500 to AED 960 (+92%)</a:t>
             </a:r>
           </a:p>
           <a:p>
@@ -6940,7 +7409,7 @@
               <a:spcBef>
                 <a:spcPts val="1600"/>
               </a:spcBef>
-              <a:defRPr sz="1150" i="1">
+              <a:defRPr sz="1100">
                 <a:solidFill>
                   <a:srgbClr val="8CC3AA"/>
                 </a:solidFill>
@@ -6948,7 +7417,11 @@
               </a:defRPr>
             </a:pPr>
             <a:r>
-              <a:t>This is an illustrative example; savings are not guaranteed or a card benefit.</a:t>
+              <a:t>• Annual Impact: Over 12 months, this reallocation preserves AED 5,520 in additional liquidity without expanding base income.</a:t>
+            </a:r>
+            <a:br/>
+            <a:r>
+              <a:t>• Academic Disclosure: Illustrative educational scenario; individual savings depend on personal consumption habits and do not reflect guaranteed financial card yields.</a:t>
             </a:r>
           </a:p>
         </p:txBody>
@@ -7042,7 +7515,7 @@
               </a:defRPr>
             </a:pPr>
             <a:r>
-              <a:t>EDUCATE - EQUIP - CONNECT IMPLEMENTATION</a:t>
+              <a:t>EDUCATE - EQUIP - CONNECT OPERATIONAL ROLLOUT</a:t>
             </a:r>
           </a:p>
         </p:txBody>
@@ -7115,7 +7588,7 @@
           <a:lstStyle/>
           <a:p>
             <a:pPr>
-              <a:defRPr sz="1500" b="1">
+              <a:defRPr sz="1400" b="1">
                 <a:solidFill>
                   <a:srgbClr val="A7F3D0"/>
                 </a:solidFill>
@@ -7123,7 +7596,7 @@
               </a:defRPr>
             </a:pPr>
             <a:r>
-              <a:t>EDUCATE:</a:t>
+              <a:t>EDUCATE (AWARENESS)</a:t>
             </a:r>
           </a:p>
           <a:p>
@@ -7139,12 +7612,12 @@
               </a:defRPr>
             </a:pPr>
             <a:r>
-              <a:t>• Publish two weekly Instagram and TikTok posts about budgeting, rent, transport and saving.</a:t>
+              <a:t>• Bi-Weekly Digital Dissemination: Release two weekly educational posts/reels across Instagram and TikTok addressing rent calculators, commute planning, and saving tips.</a:t>
             </a:r>
             <a:br/>
             <a:br/>
             <a:r>
-              <a:t>• Run six practical workshops through universities, employers and community organisations.</a:t>
+              <a:t>• Practical Seminar Series: Host 6 interactive workshops facilitated across university campuses, corporate workplaces, and community hubs.</a:t>
             </a:r>
           </a:p>
         </p:txBody>
@@ -7217,7 +7690,7 @@
           <a:lstStyle/>
           <a:p>
             <a:pPr>
-              <a:defRPr sz="1500" b="1">
+              <a:defRPr sz="1400" b="1">
                 <a:solidFill>
                   <a:srgbClr val="A7F3D0"/>
                 </a:solidFill>
@@ -7225,7 +7698,7 @@
               </a:defRPr>
             </a:pPr>
             <a:r>
-              <a:t>EQUIP:</a:t>
+              <a:t>EQUIP (TOOL DELIVERY)</a:t>
             </a:r>
           </a:p>
           <a:p>
@@ -7241,17 +7714,17 @@
               </a:defRPr>
             </a:pPr>
             <a:r>
-              <a:t>• Create a campaign webpage with a free budget planner, savings calculator and practical guides.</a:t>
+              <a:t>• Digital Campaign Portal: Centralized hub hosting interactive budget worksheets, expense calculators, and downloadable guides.</a:t>
             </a:r>
             <a:br/>
             <a:br/>
             <a:r>
-              <a:t>• Promote it through QR codes and partner newsletters.</a:t>
+              <a:t>• Physical-to-Digital Funnels: QR code displays in high-traffic youth hubs and partner e-newsletters.</a:t>
             </a:r>
             <a:br/>
             <a:br/>
             <a:r>
-              <a:t>• Launch a "30-Day Budget Challenge" to help participants track spending and set savings goals.</a:t>
+              <a:t>• 30-Day Budget Challenge: Gamified tracking habit driving structured savings goals.</a:t>
             </a:r>
           </a:p>
         </p:txBody>
@@ -7324,7 +7797,7 @@
           <a:lstStyle/>
           <a:p>
             <a:pPr>
-              <a:defRPr sz="1500" b="1">
+              <a:defRPr sz="1400" b="1">
                 <a:solidFill>
                   <a:srgbClr val="A7F3D0"/>
                 </a:solidFill>
@@ -7332,7 +7805,7 @@
               </a:defRPr>
             </a:pPr>
             <a:r>
-              <a:t>CONNECT:</a:t>
+              <a:t>CONNECT (ALLIANCES)</a:t>
             </a:r>
           </a:p>
           <a:p>
@@ -7348,17 +7821,12 @@
               </a:defRPr>
             </a:pPr>
             <a:r>
-              <a:t>• Seek educational collaboration with Zywa, using its money-management app and prepaid-card model to explain spending control.</a:t>
+              <a:t>• Zywa Youth Banking Alliance: Educational alignment utilizing mobile app budgeting controls and prepaid spending guardrails.</a:t>
             </a:r>
             <a:br/>
             <a:br/>
             <a:r>
-              <a:t>• Seek partnerships with banks, property providers, restaurants and discount platforms, including Fazaa, to share cost-saving opportunities.</a:t>
-            </a:r>
-            <a:br/>
-            <a:br/>
-            <a:r>
-              <a:t>• Clearly explain eligibility and offer conditions.</a:t>
+              <a:t>• Corporate &amp; Merchant Affiliations: Establish cost-reduction partnerships with banks, property agencies, dining outlets, and Fazaa discount networks with clear eligibility disclosures.</a:t>
             </a:r>
           </a:p>
         </p:txBody>
@@ -7452,7 +7920,7 @@
               </a:defRPr>
             </a:pPr>
             <a:r>
-              <a:t>DURATION: 12 MONTHS. TOTAL: AED 50,000</a:t>
+              <a:t>12-MONTH ALLOCATION &amp; COST GOVERNANCE (AED 50,000)</a:t>
             </a:r>
           </a:p>
         </p:txBody>
@@ -8154,13 +8622,13 @@
               </a:defRPr>
             </a:pPr>
             <a:r>
-              <a:t>COST CONTROL GUIDELINES</a:t>
+              <a:t>FISCAL GOVERNANCE &amp; CONTROL</a:t>
             </a:r>
           </a:p>
           <a:p>
             <a:pPr>
               <a:spcBef>
-                <a:spcPts val="1400"/>
+                <a:spcPts val="1200"/>
               </a:spcBef>
               <a:defRPr sz="1100">
                 <a:solidFill>
@@ -8170,13 +8638,13 @@
               </a:defRPr>
             </a:pPr>
             <a:r>
-              <a:t>• Seek free venues, volunteer speakers and promotion through partner networks.</a:t>
+              <a:t>• In-Kind Venue &amp; Speaker Sourcing: Secure complimentary university lecture halls, voluntary industry speakers, and unpaid institutional distribution networks.</a:t>
             </a:r>
           </a:p>
           <a:p>
             <a:pPr>
               <a:spcBef>
-                <a:spcPts val="1400"/>
+                <a:spcPts val="1200"/>
               </a:spcBef>
               <a:defRPr sz="1100">
                 <a:solidFill>
@@ -8186,13 +8654,13 @@
               </a:defRPr>
             </a:pPr>
             <a:r>
-              <a:t>• Use existing YFWD staff and reusable materials to control costs.</a:t>
+              <a:t>• Internal Resource Optimization: Utilize existing YFWD personnel and reusable display materials to minimize agency and overhead costs.</a:t>
             </a:r>
           </a:p>
           <a:p>
             <a:pPr>
               <a:spcBef>
-                <a:spcPts val="1400"/>
+                <a:spcPts val="1200"/>
               </a:spcBef>
               <a:defRPr sz="1100">
                 <a:solidFill>
@@ -8202,7 +8670,7 @@
               </a:defRPr>
             </a:pPr>
             <a:r>
-              <a:t>• Confirm supplier prices before spending and review the budget monthly.</a:t>
+              <a:t>• Pre-Commitment Pricing Audits: Validate vendor bids prior to fund disbursement and execute comprehensive monthly budget variance reviews.</a:t>
             </a:r>
           </a:p>
         </p:txBody>

</xml_diff>